<commit_message>
Avancement Script Présentation et réorganisation des fichiers
</commit_message>
<xml_diff>
--- a/CR/Presentation_PFE.pptx
+++ b/CR/Presentation_PFE.pptx
@@ -5,7 +5,7 @@
     <p:sldMasterId id="2147483648" r:id="rId1"/>
   </p:sldMasterIdLst>
   <p:notesMasterIdLst>
-    <p:notesMasterId r:id="rId15"/>
+    <p:notesMasterId r:id="rId16"/>
   </p:notesMasterIdLst>
   <p:sldIdLst>
     <p:sldId id="256" r:id="rId4"/>
@@ -19,6 +19,7 @@
     <p:sldId id="264" r:id="rId12"/>
     <p:sldId id="265" r:id="rId13"/>
     <p:sldId id="266" r:id="rId14"/>
+    <p:sldId id="267" r:id="rId15"/>
   </p:sldIdLst>
   <p:sldSz cx="12192000" cy="6858000"/>
   <p:notesSz cx="6858000" cy="9144000"/>
@@ -144,7 +145,7 @@
       </p:grpSpPr>
       <p:sp>
         <p:nvSpPr>
-          <p:cNvPr id="2015663531" name="Espace réservé d'en-tête 1"/>
+          <p:cNvPr id="2128463302" name="Espace réservé d'en-tête 1"/>
           <p:cNvSpPr>
             <a:spLocks noGrp="1"/>
           </p:cNvSpPr>
@@ -178,7 +179,7 @@
       </p:sp>
       <p:sp>
         <p:nvSpPr>
-          <p:cNvPr id="798792798" name="Espace réservé pour la date 2"/>
+          <p:cNvPr id="1238152498" name="Espace réservé pour la date 2"/>
           <p:cNvSpPr>
             <a:spLocks noGrp="1"/>
           </p:cNvSpPr>
@@ -216,7 +217,7 @@
       </p:sp>
       <p:sp>
         <p:nvSpPr>
-          <p:cNvPr id="875543250" name="Espace réservé pour l'image de la diapositive 3"/>
+          <p:cNvPr id="1588624565" name="Espace réservé pour l'image de la diapositive 3"/>
           <p:cNvSpPr>
             <a:spLocks noChangeAspect="1" noGrp="1" noRot="1"/>
           </p:cNvSpPr>
@@ -252,7 +253,7 @@
       </p:sp>
       <p:sp>
         <p:nvSpPr>
-          <p:cNvPr id="1197618634" name="Remarques Espace réservé 4"/>
+          <p:cNvPr id="1878345429" name="Remarques Espace réservé 4"/>
           <p:cNvSpPr>
             <a:spLocks noGrp="1"/>
           </p:cNvSpPr>
@@ -326,7 +327,7 @@
       </p:sp>
       <p:sp>
         <p:nvSpPr>
-          <p:cNvPr id="737484644" name="Espace réservé du pied de page 5"/>
+          <p:cNvPr id="753105181" name="Espace réservé du pied de page 5"/>
           <p:cNvSpPr>
             <a:spLocks noGrp="1"/>
           </p:cNvSpPr>
@@ -360,7 +361,7 @@
       </p:sp>
       <p:sp>
         <p:nvSpPr>
-          <p:cNvPr id="576544343" name="Espace réservé du numéro de diapositive 6"/>
+          <p:cNvPr id="1262973189" name="Espace réservé du numéro de diapositive 6"/>
           <p:cNvSpPr>
             <a:spLocks noGrp="1"/>
           </p:cNvSpPr>
@@ -514,7 +515,7 @@
       </p:grpSpPr>
       <p:sp>
         <p:nvSpPr>
-          <p:cNvPr id="385896177" name="Espace réservé pour l'image de la diapositive 1"/>
+          <p:cNvPr id="1652278106" name="Espace réservé pour l'image de la diapositive 1"/>
           <p:cNvSpPr>
             <a:spLocks noChangeAspect="1" noGrp="1" noRot="1"/>
           </p:cNvSpPr>
@@ -531,7 +532,7 @@
       </p:sp>
       <p:sp>
         <p:nvSpPr>
-          <p:cNvPr id="1463446305" name="Remarques Espace réservé 2"/>
+          <p:cNvPr id="840015111" name="Remarques Espace réservé 2"/>
           <p:cNvSpPr>
             <a:spLocks noGrp="1"/>
           </p:cNvSpPr>
@@ -556,7 +557,7 @@
       </p:sp>
       <p:sp>
         <p:nvSpPr>
-          <p:cNvPr id="2063530859" name="Espace réservé pour le numéro de diapositive 3"/>
+          <p:cNvPr id="624867096" name="Espace réservé pour le numéro de diapositive 3"/>
           <p:cNvSpPr>
             <a:spLocks noGrp="1"/>
           </p:cNvSpPr>
@@ -607,7 +608,7 @@
       </p:grpSpPr>
       <p:sp>
         <p:nvSpPr>
-          <p:cNvPr id="2" name="Slide Image Placeholder 1"/>
+          <p:cNvPr id="1682178005" name="Slide Image Placeholder 1"/>
           <p:cNvSpPr>
             <a:spLocks noChangeAspect="1" noGrp="1" noRot="1"/>
           </p:cNvSpPr>
@@ -619,7 +620,7 @@
       </p:sp>
       <p:sp>
         <p:nvSpPr>
-          <p:cNvPr id="3" name="Notes Placeholder 2"/>
+          <p:cNvPr id="125420946" name="Notes Placeholder 2"/>
           <p:cNvSpPr>
             <a:spLocks noGrp="1"/>
           </p:cNvSpPr>
@@ -641,7 +642,7 @@
       </p:sp>
       <p:sp>
         <p:nvSpPr>
-          <p:cNvPr id="4" name="Slide Number Placeholder 3"/>
+          <p:cNvPr id="355278959" name="Slide Number Placeholder 3"/>
           <p:cNvSpPr>
             <a:spLocks noGrp="1"/>
           </p:cNvSpPr>
@@ -657,7 +658,7 @@
             <a:pPr>
               <a:defRPr/>
             </a:pPr>
-            <a:fld id="{66022927-5078-EE08-45A7-AD96B8C99A3E}" type="slidenum">
+            <a:fld id="{33A99C6E-1B03-FE2B-1F63-CEFDE5734355}" type="slidenum">
               <a:rPr/>
               <a:t/>
             </a:fld>
@@ -692,7 +693,7 @@
       </p:grpSpPr>
       <p:sp>
         <p:nvSpPr>
-          <p:cNvPr id="2" name="Slide Image Placeholder 1"/>
+          <p:cNvPr id="53974595" name="Slide Image Placeholder 1"/>
           <p:cNvSpPr>
             <a:spLocks noChangeAspect="1" noGrp="1" noRot="1"/>
           </p:cNvSpPr>
@@ -704,7 +705,7 @@
       </p:sp>
       <p:sp>
         <p:nvSpPr>
-          <p:cNvPr id="3" name="Notes Placeholder 2"/>
+          <p:cNvPr id="1022126503" name="Notes Placeholder 2"/>
           <p:cNvSpPr>
             <a:spLocks noGrp="1"/>
           </p:cNvSpPr>
@@ -726,7 +727,92 @@
       </p:sp>
       <p:sp>
         <p:nvSpPr>
-          <p:cNvPr id="4" name="Slide Number Placeholder 3"/>
+          <p:cNvPr id="329397233" name="Slide Number Placeholder 3"/>
+          <p:cNvSpPr>
+            <a:spLocks noGrp="1"/>
+          </p:cNvSpPr>
+          <p:nvPr>
+            <p:ph type="sldNum" sz="quarter" idx="10"/>
+          </p:nvPr>
+        </p:nvSpPr>
+        <p:spPr bwMode="auto"/>
+        <p:txBody>
+          <a:bodyPr/>
+          <a:lstStyle/>
+          <a:p>
+            <a:pPr>
+              <a:defRPr/>
+            </a:pPr>
+            <a:fld id="{66022927-5078-EE08-45A7-AD96B8C99A3E}" type="slidenum">
+              <a:rPr/>
+              <a:t/>
+            </a:fld>
+            <a:endParaRPr/>
+          </a:p>
+        </p:txBody>
+      </p:sp>
+    </p:spTree>
+  </p:cSld>
+  <p:clrMapOvr>
+    <a:masterClrMapping/>
+  </p:clrMapOvr>
+</p:notes>
+</file>
+
+<file path=ppt/notesSlides/notesSlide12.xml><?xml version="1.0" encoding="utf-8"?>
+<p:notes xmlns:a="http://schemas.openxmlformats.org/drawingml/2006/main" xmlns:r="http://schemas.openxmlformats.org/officeDocument/2006/relationships" xmlns:p="http://schemas.openxmlformats.org/presentationml/2006/main" xmlns:m="http://schemas.openxmlformats.org/officeDocument/2006/math" xmlns:w="http://schemas.openxmlformats.org/wordprocessingml/2006/main">
+  <p:cSld name="">
+    <p:spTree>
+      <p:nvGrpSpPr>
+        <p:cNvPr id="1" name=""/>
+        <p:cNvGrpSpPr/>
+        <p:nvPr/>
+      </p:nvGrpSpPr>
+      <p:grpSpPr bwMode="auto">
+        <a:xfrm>
+          <a:off x="0" y="0"/>
+          <a:ext cx="0" cy="0"/>
+          <a:chOff x="0" y="0"/>
+          <a:chExt cx="0" cy="0"/>
+        </a:xfrm>
+      </p:grpSpPr>
+      <p:sp>
+        <p:nvSpPr>
+          <p:cNvPr id="889606506" name="Slide Image Placeholder 1"/>
+          <p:cNvSpPr>
+            <a:spLocks noChangeAspect="1" noGrp="1" noRot="1"/>
+          </p:cNvSpPr>
+          <p:nvPr>
+            <p:ph type="sldImg"/>
+          </p:nvPr>
+        </p:nvSpPr>
+        <p:spPr bwMode="auto"/>
+      </p:sp>
+      <p:sp>
+        <p:nvSpPr>
+          <p:cNvPr id="486591266" name="Notes Placeholder 2"/>
+          <p:cNvSpPr>
+            <a:spLocks noGrp="1"/>
+          </p:cNvSpPr>
+          <p:nvPr>
+            <p:ph type="body" idx="1"/>
+          </p:nvPr>
+        </p:nvSpPr>
+        <p:spPr bwMode="auto"/>
+        <p:txBody>
+          <a:bodyPr/>
+          <a:lstStyle/>
+          <a:p>
+            <a:pPr>
+              <a:defRPr/>
+            </a:pPr>
+            <a:endParaRPr/>
+          </a:p>
+        </p:txBody>
+      </p:sp>
+      <p:sp>
+        <p:nvSpPr>
+          <p:cNvPr id="639475785" name="Slide Number Placeholder 3"/>
           <p:cNvSpPr>
             <a:spLocks noGrp="1"/>
           </p:cNvSpPr>
@@ -777,7 +863,7 @@
       </p:grpSpPr>
       <p:sp>
         <p:nvSpPr>
-          <p:cNvPr id="2093437415" name="Slide Image Placeholder 1"/>
+          <p:cNvPr id="1869631353" name="Slide Image Placeholder 1"/>
           <p:cNvSpPr>
             <a:spLocks noChangeAspect="1" noGrp="1" noRot="1"/>
           </p:cNvSpPr>
@@ -789,7 +875,7 @@
       </p:sp>
       <p:sp>
         <p:nvSpPr>
-          <p:cNvPr id="1322608365" name="Notes Placeholder 2"/>
+          <p:cNvPr id="1954121547" name="Notes Placeholder 2"/>
           <p:cNvSpPr>
             <a:spLocks noGrp="1"/>
           </p:cNvSpPr>
@@ -811,7 +897,7 @@
       </p:sp>
       <p:sp>
         <p:nvSpPr>
-          <p:cNvPr id="1409061653" name="Slide Number Placeholder 3"/>
+          <p:cNvPr id="41677471" name="Slide Number Placeholder 3"/>
           <p:cNvSpPr>
             <a:spLocks noGrp="1"/>
           </p:cNvSpPr>
@@ -862,7 +948,7 @@
       </p:grpSpPr>
       <p:sp>
         <p:nvSpPr>
-          <p:cNvPr id="1106592995" name="Slide Image Placeholder 1"/>
+          <p:cNvPr id="2041983673" name="Slide Image Placeholder 1"/>
           <p:cNvSpPr>
             <a:spLocks noChangeAspect="1" noGrp="1" noRot="1"/>
           </p:cNvSpPr>
@@ -874,7 +960,7 @@
       </p:sp>
       <p:sp>
         <p:nvSpPr>
-          <p:cNvPr id="199673378" name="Notes Placeholder 2"/>
+          <p:cNvPr id="593331175" name="Notes Placeholder 2"/>
           <p:cNvSpPr>
             <a:spLocks noGrp="1"/>
           </p:cNvSpPr>
@@ -896,7 +982,7 @@
       </p:sp>
       <p:sp>
         <p:nvSpPr>
-          <p:cNvPr id="419936914" name="Slide Number Placeholder 3"/>
+          <p:cNvPr id="574993108" name="Slide Number Placeholder 3"/>
           <p:cNvSpPr>
             <a:spLocks noGrp="1"/>
           </p:cNvSpPr>
@@ -947,7 +1033,7 @@
       </p:grpSpPr>
       <p:sp>
         <p:nvSpPr>
-          <p:cNvPr id="1758305178" name="Slide Image Placeholder 1"/>
+          <p:cNvPr id="1755137978" name="Slide Image Placeholder 1"/>
           <p:cNvSpPr>
             <a:spLocks noChangeAspect="1" noGrp="1" noRot="1"/>
           </p:cNvSpPr>
@@ -959,7 +1045,7 @@
       </p:sp>
       <p:sp>
         <p:nvSpPr>
-          <p:cNvPr id="71787967" name="Notes Placeholder 2"/>
+          <p:cNvPr id="1258010222" name="Notes Placeholder 2"/>
           <p:cNvSpPr>
             <a:spLocks noGrp="1"/>
           </p:cNvSpPr>
@@ -981,7 +1067,7 @@
       </p:sp>
       <p:sp>
         <p:nvSpPr>
-          <p:cNvPr id="94379727" name="Slide Number Placeholder 3"/>
+          <p:cNvPr id="768425974" name="Slide Number Placeholder 3"/>
           <p:cNvSpPr>
             <a:spLocks noGrp="1"/>
           </p:cNvSpPr>
@@ -1032,7 +1118,7 @@
       </p:grpSpPr>
       <p:sp>
         <p:nvSpPr>
-          <p:cNvPr id="187116676" name="Slide Image Placeholder 1"/>
+          <p:cNvPr id="2" name="Slide Image Placeholder 1"/>
           <p:cNvSpPr>
             <a:spLocks noChangeAspect="1" noGrp="1" noRot="1"/>
           </p:cNvSpPr>
@@ -1044,7 +1130,7 @@
       </p:sp>
       <p:sp>
         <p:nvSpPr>
-          <p:cNvPr id="77199687" name="Notes Placeholder 2"/>
+          <p:cNvPr id="3" name="Notes Placeholder 2"/>
           <p:cNvSpPr>
             <a:spLocks noGrp="1"/>
           </p:cNvSpPr>
@@ -1066,7 +1152,7 @@
       </p:sp>
       <p:sp>
         <p:nvSpPr>
-          <p:cNvPr id="1990894254" name="Slide Number Placeholder 3"/>
+          <p:cNvPr id="4" name="Slide Number Placeholder 3"/>
           <p:cNvSpPr>
             <a:spLocks noGrp="1"/>
           </p:cNvSpPr>
@@ -1082,7 +1168,7 @@
             <a:pPr>
               <a:defRPr/>
             </a:pPr>
-            <a:fld id="{4CDBE6F6-7276-366D-C2A1-41D736A08596}" type="slidenum">
+            <a:fld id="{90636C0C-A141-4F24-F2E8-5BCA1492A67B}" type="slidenum">
               <a:rPr/>
               <a:t/>
             </a:fld>
@@ -1117,7 +1203,7 @@
       </p:grpSpPr>
       <p:sp>
         <p:nvSpPr>
-          <p:cNvPr id="211657766" name="Slide Image Placeholder 1"/>
+          <p:cNvPr id="60195035" name="Slide Image Placeholder 1"/>
           <p:cNvSpPr>
             <a:spLocks noChangeAspect="1" noGrp="1" noRot="1"/>
           </p:cNvSpPr>
@@ -1129,7 +1215,7 @@
       </p:sp>
       <p:sp>
         <p:nvSpPr>
-          <p:cNvPr id="706899795" name="Notes Placeholder 2"/>
+          <p:cNvPr id="978453481" name="Notes Placeholder 2"/>
           <p:cNvSpPr>
             <a:spLocks noGrp="1"/>
           </p:cNvSpPr>
@@ -1151,7 +1237,7 @@
       </p:sp>
       <p:sp>
         <p:nvSpPr>
-          <p:cNvPr id="947578544" name="Slide Number Placeholder 3"/>
+          <p:cNvPr id="136152076" name="Slide Number Placeholder 3"/>
           <p:cNvSpPr>
             <a:spLocks noGrp="1"/>
           </p:cNvSpPr>
@@ -1202,7 +1288,7 @@
       </p:grpSpPr>
       <p:sp>
         <p:nvSpPr>
-          <p:cNvPr id="242396792" name="Slide Image Placeholder 1"/>
+          <p:cNvPr id="36067969" name="Slide Image Placeholder 1"/>
           <p:cNvSpPr>
             <a:spLocks noChangeAspect="1" noGrp="1" noRot="1"/>
           </p:cNvSpPr>
@@ -1214,7 +1300,7 @@
       </p:sp>
       <p:sp>
         <p:nvSpPr>
-          <p:cNvPr id="1770390964" name="Notes Placeholder 2"/>
+          <p:cNvPr id="1597563962" name="Notes Placeholder 2"/>
           <p:cNvSpPr>
             <a:spLocks noGrp="1"/>
           </p:cNvSpPr>
@@ -1232,11 +1318,27 @@
             </a:pPr>
             <a:endParaRPr/>
           </a:p>
-        </p:txBody>
-      </p:sp>
-      <p:sp>
-        <p:nvSpPr>
-          <p:cNvPr id="1913738802" name="Slide Number Placeholder 3"/>
+          <a:p>
+            <a:pPr>
+              <a:defRPr/>
+            </a:pPr>
+            <a:endParaRPr/>
+          </a:p>
+          <a:p>
+            <a:pPr>
+              <a:defRPr/>
+            </a:pPr>
+            <a:r>
+              <a:rPr lang="fr-FR"/>
+              <a:t>.</a:t>
+            </a:r>
+            <a:endParaRPr/>
+          </a:p>
+        </p:txBody>
+      </p:sp>
+      <p:sp>
+        <p:nvSpPr>
+          <p:cNvPr id="468591994" name="Slide Number Placeholder 3"/>
           <p:cNvSpPr>
             <a:spLocks noGrp="1"/>
           </p:cNvSpPr>
@@ -1252,7 +1354,7 @@
             <a:pPr>
               <a:defRPr/>
             </a:pPr>
-            <a:fld id="{9A4266D5-73A1-54C4-04CE-D4B3E2B50860}" type="slidenum">
+            <a:fld id="{4CDBE6F6-7276-366D-C2A1-41D736A08596}" type="slidenum">
               <a:rPr/>
               <a:t/>
             </a:fld>
@@ -1287,7 +1389,7 @@
       </p:grpSpPr>
       <p:sp>
         <p:nvSpPr>
-          <p:cNvPr id="2" name="Slide Image Placeholder 1"/>
+          <p:cNvPr id="686757556" name="Slide Image Placeholder 1"/>
           <p:cNvSpPr>
             <a:spLocks noChangeAspect="1" noGrp="1" noRot="1"/>
           </p:cNvSpPr>
@@ -1299,7 +1401,7 @@
       </p:sp>
       <p:sp>
         <p:nvSpPr>
-          <p:cNvPr id="3" name="Notes Placeholder 2"/>
+          <p:cNvPr id="268628443" name="Notes Placeholder 2"/>
           <p:cNvSpPr>
             <a:spLocks noGrp="1"/>
           </p:cNvSpPr>
@@ -1321,7 +1423,7 @@
       </p:sp>
       <p:sp>
         <p:nvSpPr>
-          <p:cNvPr id="4" name="Slide Number Placeholder 3"/>
+          <p:cNvPr id="1715416610" name="Slide Number Placeholder 3"/>
           <p:cNvSpPr>
             <a:spLocks noGrp="1"/>
           </p:cNvSpPr>
@@ -1337,7 +1439,7 @@
             <a:pPr>
               <a:defRPr/>
             </a:pPr>
-            <a:fld id="{C7364DD0-CA69-29AB-DE81-FDF42785DA1D}" type="slidenum">
+            <a:fld id="{9A4266D5-73A1-54C4-04CE-D4B3E2B50860}" type="slidenum">
               <a:rPr/>
               <a:t/>
             </a:fld>
@@ -1372,7 +1474,7 @@
       </p:grpSpPr>
       <p:sp>
         <p:nvSpPr>
-          <p:cNvPr id="2" name="Slide Image Placeholder 1"/>
+          <p:cNvPr id="1656147949" name="Slide Image Placeholder 1"/>
           <p:cNvSpPr>
             <a:spLocks noChangeAspect="1" noGrp="1" noRot="1"/>
           </p:cNvSpPr>
@@ -1384,7 +1486,7 @@
       </p:sp>
       <p:sp>
         <p:nvSpPr>
-          <p:cNvPr id="3" name="Notes Placeholder 2"/>
+          <p:cNvPr id="166990969" name="Notes Placeholder 2"/>
           <p:cNvSpPr>
             <a:spLocks noGrp="1"/>
           </p:cNvSpPr>
@@ -1406,7 +1508,7 @@
       </p:sp>
       <p:sp>
         <p:nvSpPr>
-          <p:cNvPr id="4" name="Slide Number Placeholder 3"/>
+          <p:cNvPr id="380093423" name="Slide Number Placeholder 3"/>
           <p:cNvSpPr>
             <a:spLocks noGrp="1"/>
           </p:cNvSpPr>
@@ -1422,7 +1524,7 @@
             <a:pPr>
               <a:defRPr/>
             </a:pPr>
-            <a:fld id="{33A99C6E-1B03-FE2B-1F63-CEFDE5734355}" type="slidenum">
+            <a:fld id="{C7364DD0-CA69-29AB-DE81-FDF42785DA1D}" type="slidenum">
               <a:rPr/>
               <a:t/>
             </a:fld>
@@ -1457,7 +1559,7 @@
       </p:grpSpPr>
       <p:sp>
         <p:nvSpPr>
-          <p:cNvPr id="1662048293" name="Titre 1"/>
+          <p:cNvPr id="1683512492" name="Titre 1"/>
           <p:cNvSpPr>
             <a:spLocks noGrp="1"/>
           </p:cNvSpPr>
@@ -1492,7 +1594,7 @@
       </p:sp>
       <p:sp>
         <p:nvSpPr>
-          <p:cNvPr id="1240399984" name="Sous-titre 2"/>
+          <p:cNvPr id="1216109522" name="Sous-titre 2"/>
           <p:cNvSpPr>
             <a:spLocks noGrp="1"/>
           </p:cNvSpPr>
@@ -1560,7 +1662,7 @@
       </p:sp>
       <p:sp>
         <p:nvSpPr>
-          <p:cNvPr id="1490822102" name="Espace réservé de la date 3"/>
+          <p:cNvPr id="99306960" name="Espace réservé de la date 3"/>
           <p:cNvSpPr>
             <a:spLocks noGrp="1"/>
           </p:cNvSpPr>
@@ -1586,7 +1688,7 @@
       </p:sp>
       <p:sp>
         <p:nvSpPr>
-          <p:cNvPr id="705500784" name="Espace réservé du pied de page 4"/>
+          <p:cNvPr id="1290294816" name="Espace réservé du pied de page 4"/>
           <p:cNvSpPr>
             <a:spLocks noGrp="1"/>
           </p:cNvSpPr>
@@ -1608,7 +1710,7 @@
       </p:sp>
       <p:sp>
         <p:nvSpPr>
-          <p:cNvPr id="1554814798" name="Espace réservé du numéro de diapositive 5"/>
+          <p:cNvPr id="1721691789" name="Espace réservé du numéro de diapositive 5"/>
           <p:cNvSpPr>
             <a:spLocks noGrp="1"/>
           </p:cNvSpPr>
@@ -1659,7 +1761,7 @@
       </p:grpSpPr>
       <p:sp>
         <p:nvSpPr>
-          <p:cNvPr id="1303618059" name="Titre 1"/>
+          <p:cNvPr id="1960993687" name="Titre 1"/>
           <p:cNvSpPr>
             <a:spLocks noGrp="1"/>
           </p:cNvSpPr>
@@ -1685,7 +1787,7 @@
       </p:sp>
       <p:sp>
         <p:nvSpPr>
-          <p:cNvPr id="1892458327" name="Espace réservé du texte vertical 2"/>
+          <p:cNvPr id="1433729812" name="Espace réservé du texte vertical 2"/>
           <p:cNvSpPr>
             <a:spLocks noGrp="1"/>
           </p:cNvSpPr>
@@ -1751,7 +1853,7 @@
       </p:sp>
       <p:sp>
         <p:nvSpPr>
-          <p:cNvPr id="327774536" name="Espace réservé de la date 3"/>
+          <p:cNvPr id="1899957937" name="Espace réservé de la date 3"/>
           <p:cNvSpPr>
             <a:spLocks noGrp="1"/>
           </p:cNvSpPr>
@@ -1777,7 +1879,7 @@
       </p:sp>
       <p:sp>
         <p:nvSpPr>
-          <p:cNvPr id="1122112209" name="Espace réservé du pied de page 4"/>
+          <p:cNvPr id="342442691" name="Espace réservé du pied de page 4"/>
           <p:cNvSpPr>
             <a:spLocks noGrp="1"/>
           </p:cNvSpPr>
@@ -1799,7 +1901,7 @@
       </p:sp>
       <p:sp>
         <p:nvSpPr>
-          <p:cNvPr id="2139899662" name="Espace réservé du numéro de diapositive 5"/>
+          <p:cNvPr id="1214608096" name="Espace réservé du numéro de diapositive 5"/>
           <p:cNvSpPr>
             <a:spLocks noGrp="1"/>
           </p:cNvSpPr>
@@ -1850,7 +1952,7 @@
       </p:grpSpPr>
       <p:sp>
         <p:nvSpPr>
-          <p:cNvPr id="939972882" name="Titre vertical 1"/>
+          <p:cNvPr id="231631216" name="Titre vertical 1"/>
           <p:cNvSpPr>
             <a:spLocks noGrp="1"/>
           </p:cNvSpPr>
@@ -1881,7 +1983,7 @@
       </p:sp>
       <p:sp>
         <p:nvSpPr>
-          <p:cNvPr id="1963219987" name="Espace réservé du texte vertical 2"/>
+          <p:cNvPr id="1173988550" name="Espace réservé du texte vertical 2"/>
           <p:cNvSpPr>
             <a:spLocks noGrp="1"/>
           </p:cNvSpPr>
@@ -1952,7 +2054,7 @@
       </p:sp>
       <p:sp>
         <p:nvSpPr>
-          <p:cNvPr id="380805657" name="Espace réservé de la date 3"/>
+          <p:cNvPr id="804566604" name="Espace réservé de la date 3"/>
           <p:cNvSpPr>
             <a:spLocks noGrp="1"/>
           </p:cNvSpPr>
@@ -1978,7 +2080,7 @@
       </p:sp>
       <p:sp>
         <p:nvSpPr>
-          <p:cNvPr id="116931734" name="Espace réservé du pied de page 4"/>
+          <p:cNvPr id="626555013" name="Espace réservé du pied de page 4"/>
           <p:cNvSpPr>
             <a:spLocks noGrp="1"/>
           </p:cNvSpPr>
@@ -2000,7 +2102,7 @@
       </p:sp>
       <p:sp>
         <p:nvSpPr>
-          <p:cNvPr id="1490729509" name="Espace réservé du numéro de diapositive 5"/>
+          <p:cNvPr id="93878471" name="Espace réservé du numéro de diapositive 5"/>
           <p:cNvSpPr>
             <a:spLocks noGrp="1"/>
           </p:cNvSpPr>
@@ -2051,7 +2153,7 @@
       </p:grpSpPr>
       <p:sp>
         <p:nvSpPr>
-          <p:cNvPr id="1202145746" name="Titre 1"/>
+          <p:cNvPr id="46343955" name="Titre 1"/>
           <p:cNvSpPr>
             <a:spLocks noGrp="1"/>
           </p:cNvSpPr>
@@ -2077,7 +2179,7 @@
       </p:sp>
       <p:sp>
         <p:nvSpPr>
-          <p:cNvPr id="1150628727" name="Espace réservé du contenu 2"/>
+          <p:cNvPr id="725973378" name="Espace réservé du contenu 2"/>
           <p:cNvSpPr>
             <a:spLocks noGrp="1"/>
           </p:cNvSpPr>
@@ -2143,7 +2245,7 @@
       </p:sp>
       <p:sp>
         <p:nvSpPr>
-          <p:cNvPr id="924422811" name="Espace réservé de la date 3"/>
+          <p:cNvPr id="841811924" name="Espace réservé de la date 3"/>
           <p:cNvSpPr>
             <a:spLocks noGrp="1"/>
           </p:cNvSpPr>
@@ -2169,7 +2271,7 @@
       </p:sp>
       <p:sp>
         <p:nvSpPr>
-          <p:cNvPr id="758706057" name="Espace réservé du pied de page 4"/>
+          <p:cNvPr id="1637772309" name="Espace réservé du pied de page 4"/>
           <p:cNvSpPr>
             <a:spLocks noGrp="1"/>
           </p:cNvSpPr>
@@ -2191,7 +2293,7 @@
       </p:sp>
       <p:sp>
         <p:nvSpPr>
-          <p:cNvPr id="99374381" name="Espace réservé du numéro de diapositive 5"/>
+          <p:cNvPr id="1516366583" name="Espace réservé du numéro de diapositive 5"/>
           <p:cNvSpPr>
             <a:spLocks noGrp="1"/>
           </p:cNvSpPr>
@@ -2242,7 +2344,7 @@
       </p:grpSpPr>
       <p:sp>
         <p:nvSpPr>
-          <p:cNvPr id="267965318" name="Titre 1"/>
+          <p:cNvPr id="1565630997" name="Titre 1"/>
           <p:cNvSpPr>
             <a:spLocks noGrp="1"/>
           </p:cNvSpPr>
@@ -2277,7 +2379,7 @@
       </p:sp>
       <p:sp>
         <p:nvSpPr>
-          <p:cNvPr id="1871778658" name="Espace réservé du texte 2"/>
+          <p:cNvPr id="1940697875" name="Espace réservé du texte 2"/>
           <p:cNvSpPr>
             <a:spLocks noGrp="1"/>
           </p:cNvSpPr>
@@ -2399,7 +2501,7 @@
       </p:sp>
       <p:sp>
         <p:nvSpPr>
-          <p:cNvPr id="145032999" name="Espace réservé de la date 3"/>
+          <p:cNvPr id="469544301" name="Espace réservé de la date 3"/>
           <p:cNvSpPr>
             <a:spLocks noGrp="1"/>
           </p:cNvSpPr>
@@ -2425,7 +2527,7 @@
       </p:sp>
       <p:sp>
         <p:nvSpPr>
-          <p:cNvPr id="1166769557" name="Espace réservé du pied de page 4"/>
+          <p:cNvPr id="1778562157" name="Espace réservé du pied de page 4"/>
           <p:cNvSpPr>
             <a:spLocks noGrp="1"/>
           </p:cNvSpPr>
@@ -2447,7 +2549,7 @@
       </p:sp>
       <p:sp>
         <p:nvSpPr>
-          <p:cNvPr id="2103933166" name="Espace réservé du numéro de diapositive 5"/>
+          <p:cNvPr id="1504657571" name="Espace réservé du numéro de diapositive 5"/>
           <p:cNvSpPr>
             <a:spLocks noGrp="1"/>
           </p:cNvSpPr>
@@ -2498,7 +2600,7 @@
       </p:grpSpPr>
       <p:sp>
         <p:nvSpPr>
-          <p:cNvPr id="2107239229" name="Titre 1"/>
+          <p:cNvPr id="1466105429" name="Titre 1"/>
           <p:cNvSpPr>
             <a:spLocks noGrp="1"/>
           </p:cNvSpPr>
@@ -2524,7 +2626,7 @@
       </p:sp>
       <p:sp>
         <p:nvSpPr>
-          <p:cNvPr id="830757372" name="Espace réservé du contenu 2"/>
+          <p:cNvPr id="668102972" name="Espace réservé du contenu 2"/>
           <p:cNvSpPr>
             <a:spLocks noGrp="1"/>
           </p:cNvSpPr>
@@ -2595,7 +2697,7 @@
       </p:sp>
       <p:sp>
         <p:nvSpPr>
-          <p:cNvPr id="1563831490" name="Espace réservé du contenu 3"/>
+          <p:cNvPr id="1950478841" name="Espace réservé du contenu 3"/>
           <p:cNvSpPr>
             <a:spLocks noGrp="1"/>
           </p:cNvSpPr>
@@ -2666,7 +2768,7 @@
       </p:sp>
       <p:sp>
         <p:nvSpPr>
-          <p:cNvPr id="480071126" name="Espace réservé de la date 4"/>
+          <p:cNvPr id="1314838564" name="Espace réservé de la date 4"/>
           <p:cNvSpPr>
             <a:spLocks noGrp="1"/>
           </p:cNvSpPr>
@@ -2692,7 +2794,7 @@
       </p:sp>
       <p:sp>
         <p:nvSpPr>
-          <p:cNvPr id="1895661296" name="Espace réservé du pied de page 5"/>
+          <p:cNvPr id="683084425" name="Espace réservé du pied de page 5"/>
           <p:cNvSpPr>
             <a:spLocks noGrp="1"/>
           </p:cNvSpPr>
@@ -2714,7 +2816,7 @@
       </p:sp>
       <p:sp>
         <p:nvSpPr>
-          <p:cNvPr id="1055577025" name="Espace réservé du numéro de diapositive 6"/>
+          <p:cNvPr id="227372212" name="Espace réservé du numéro de diapositive 6"/>
           <p:cNvSpPr>
             <a:spLocks noGrp="1"/>
           </p:cNvSpPr>
@@ -2765,7 +2867,7 @@
       </p:grpSpPr>
       <p:sp>
         <p:nvSpPr>
-          <p:cNvPr id="1397155316" name="Titre 1"/>
+          <p:cNvPr id="1492702997" name="Titre 1"/>
           <p:cNvSpPr>
             <a:spLocks noGrp="1"/>
           </p:cNvSpPr>
@@ -2796,7 +2898,7 @@
       </p:sp>
       <p:sp>
         <p:nvSpPr>
-          <p:cNvPr id="1651647358" name="Espace réservé du texte 2"/>
+          <p:cNvPr id="1267249527" name="Espace réservé du texte 2"/>
           <p:cNvSpPr>
             <a:spLocks noGrp="1"/>
           </p:cNvSpPr>
@@ -2864,7 +2966,7 @@
       </p:sp>
       <p:sp>
         <p:nvSpPr>
-          <p:cNvPr id="1400436157" name="Espace réservé du contenu 3"/>
+          <p:cNvPr id="106020727" name="Espace réservé du contenu 3"/>
           <p:cNvSpPr>
             <a:spLocks noGrp="1"/>
           </p:cNvSpPr>
@@ -2935,7 +3037,7 @@
       </p:sp>
       <p:sp>
         <p:nvSpPr>
-          <p:cNvPr id="1995070145" name="Espace réservé du texte 4"/>
+          <p:cNvPr id="2071568336" name="Espace réservé du texte 4"/>
           <p:cNvSpPr>
             <a:spLocks noGrp="1"/>
           </p:cNvSpPr>
@@ -3003,7 +3105,7 @@
       </p:sp>
       <p:sp>
         <p:nvSpPr>
-          <p:cNvPr id="1561444073" name="Espace réservé du contenu 5"/>
+          <p:cNvPr id="635586545" name="Espace réservé du contenu 5"/>
           <p:cNvSpPr>
             <a:spLocks noGrp="1"/>
           </p:cNvSpPr>
@@ -3074,7 +3176,7 @@
       </p:sp>
       <p:sp>
         <p:nvSpPr>
-          <p:cNvPr id="97026910" name="Espace réservé de la date 6"/>
+          <p:cNvPr id="1026786876" name="Espace réservé de la date 6"/>
           <p:cNvSpPr>
             <a:spLocks noGrp="1"/>
           </p:cNvSpPr>
@@ -3100,7 +3202,7 @@
       </p:sp>
       <p:sp>
         <p:nvSpPr>
-          <p:cNvPr id="1144942243" name="Espace réservé du pied de page 7"/>
+          <p:cNvPr id="622294265" name="Espace réservé du pied de page 7"/>
           <p:cNvSpPr>
             <a:spLocks noGrp="1"/>
           </p:cNvSpPr>
@@ -3122,7 +3224,7 @@
       </p:sp>
       <p:sp>
         <p:nvSpPr>
-          <p:cNvPr id="1827100226" name="Espace réservé du numéro de diapositive 8"/>
+          <p:cNvPr id="388807381" name="Espace réservé du numéro de diapositive 8"/>
           <p:cNvSpPr>
             <a:spLocks noGrp="1"/>
           </p:cNvSpPr>
@@ -3173,7 +3275,7 @@
       </p:grpSpPr>
       <p:sp>
         <p:nvSpPr>
-          <p:cNvPr id="1062260299" name="Titre 1"/>
+          <p:cNvPr id="1757816934" name="Titre 1"/>
           <p:cNvSpPr>
             <a:spLocks noGrp="1"/>
           </p:cNvSpPr>
@@ -3199,7 +3301,7 @@
       </p:sp>
       <p:sp>
         <p:nvSpPr>
-          <p:cNvPr id="610753270" name="Espace réservé de la date 2"/>
+          <p:cNvPr id="861319340" name="Espace réservé de la date 2"/>
           <p:cNvSpPr>
             <a:spLocks noGrp="1"/>
           </p:cNvSpPr>
@@ -3225,7 +3327,7 @@
       </p:sp>
       <p:sp>
         <p:nvSpPr>
-          <p:cNvPr id="1410394645" name="Espace réservé du pied de page 3"/>
+          <p:cNvPr id="266374064" name="Espace réservé du pied de page 3"/>
           <p:cNvSpPr>
             <a:spLocks noGrp="1"/>
           </p:cNvSpPr>
@@ -3247,7 +3349,7 @@
       </p:sp>
       <p:sp>
         <p:nvSpPr>
-          <p:cNvPr id="398827524" name="Espace réservé du numéro de diapositive 4"/>
+          <p:cNvPr id="23023009" name="Espace réservé du numéro de diapositive 4"/>
           <p:cNvSpPr>
             <a:spLocks noGrp="1"/>
           </p:cNvSpPr>
@@ -3298,7 +3400,7 @@
       </p:grpSpPr>
       <p:sp>
         <p:nvSpPr>
-          <p:cNvPr id="1352240291" name="Espace réservé de la date 1"/>
+          <p:cNvPr id="1701295770" name="Espace réservé de la date 1"/>
           <p:cNvSpPr>
             <a:spLocks noGrp="1"/>
           </p:cNvSpPr>
@@ -3324,7 +3426,7 @@
       </p:sp>
       <p:sp>
         <p:nvSpPr>
-          <p:cNvPr id="836989763" name="Espace réservé du pied de page 2"/>
+          <p:cNvPr id="1616733575" name="Espace réservé du pied de page 2"/>
           <p:cNvSpPr>
             <a:spLocks noGrp="1"/>
           </p:cNvSpPr>
@@ -3346,7 +3448,7 @@
       </p:sp>
       <p:sp>
         <p:nvSpPr>
-          <p:cNvPr id="946750421" name="Espace réservé du numéro de diapositive 3"/>
+          <p:cNvPr id="536911997" name="Espace réservé du numéro de diapositive 3"/>
           <p:cNvSpPr>
             <a:spLocks noGrp="1"/>
           </p:cNvSpPr>
@@ -3397,7 +3499,7 @@
       </p:grpSpPr>
       <p:sp>
         <p:nvSpPr>
-          <p:cNvPr id="1724930880" name="Titre 1"/>
+          <p:cNvPr id="1793600383" name="Titre 1"/>
           <p:cNvSpPr>
             <a:spLocks noGrp="1"/>
           </p:cNvSpPr>
@@ -3432,7 +3534,7 @@
       </p:sp>
       <p:sp>
         <p:nvSpPr>
-          <p:cNvPr id="879073902" name="Espace réservé du contenu 2"/>
+          <p:cNvPr id="2126280210" name="Espace réservé du contenu 2"/>
           <p:cNvSpPr>
             <a:spLocks noGrp="1"/>
           </p:cNvSpPr>
@@ -3531,7 +3633,7 @@
       </p:sp>
       <p:sp>
         <p:nvSpPr>
-          <p:cNvPr id="1651204453" name="Espace réservé du texte 3"/>
+          <p:cNvPr id="2058330930" name="Espace réservé du texte 3"/>
           <p:cNvSpPr>
             <a:spLocks noGrp="1"/>
           </p:cNvSpPr>
@@ -3599,7 +3701,7 @@
       </p:sp>
       <p:sp>
         <p:nvSpPr>
-          <p:cNvPr id="454302228" name="Espace réservé de la date 4"/>
+          <p:cNvPr id="408373664" name="Espace réservé de la date 4"/>
           <p:cNvSpPr>
             <a:spLocks noGrp="1"/>
           </p:cNvSpPr>
@@ -3625,7 +3727,7 @@
       </p:sp>
       <p:sp>
         <p:nvSpPr>
-          <p:cNvPr id="2050689378" name="Espace réservé du pied de page 5"/>
+          <p:cNvPr id="2131235572" name="Espace réservé du pied de page 5"/>
           <p:cNvSpPr>
             <a:spLocks noGrp="1"/>
           </p:cNvSpPr>
@@ -3647,7 +3749,7 @@
       </p:sp>
       <p:sp>
         <p:nvSpPr>
-          <p:cNvPr id="791696313" name="Espace réservé du numéro de diapositive 6"/>
+          <p:cNvPr id="466771879" name="Espace réservé du numéro de diapositive 6"/>
           <p:cNvSpPr>
             <a:spLocks noGrp="1"/>
           </p:cNvSpPr>
@@ -3698,7 +3800,7 @@
       </p:grpSpPr>
       <p:sp>
         <p:nvSpPr>
-          <p:cNvPr id="422316497" name="Titre 1"/>
+          <p:cNvPr id="813432443" name="Titre 1"/>
           <p:cNvSpPr>
             <a:spLocks noGrp="1"/>
           </p:cNvSpPr>
@@ -3733,7 +3835,7 @@
       </p:sp>
       <p:sp>
         <p:nvSpPr>
-          <p:cNvPr id="1931571289" name="Espace réservé pour une image 2"/>
+          <p:cNvPr id="1851571280" name="Espace réservé pour une image 2"/>
           <p:cNvSpPr>
             <a:spLocks noChangeAspect="1" noGrp="1"/>
           </p:cNvSpPr>
@@ -3801,7 +3903,7 @@
       </p:sp>
       <p:sp>
         <p:nvSpPr>
-          <p:cNvPr id="326188886" name="Espace réservé du texte 3"/>
+          <p:cNvPr id="623502358" name="Espace réservé du texte 3"/>
           <p:cNvSpPr>
             <a:spLocks noGrp="1"/>
           </p:cNvSpPr>
@@ -3869,7 +3971,7 @@
       </p:sp>
       <p:sp>
         <p:nvSpPr>
-          <p:cNvPr id="859907290" name="Espace réservé de la date 4"/>
+          <p:cNvPr id="310511157" name="Espace réservé de la date 4"/>
           <p:cNvSpPr>
             <a:spLocks noGrp="1"/>
           </p:cNvSpPr>
@@ -3895,7 +3997,7 @@
       </p:sp>
       <p:sp>
         <p:nvSpPr>
-          <p:cNvPr id="1933874769" name="Espace réservé du pied de page 5"/>
+          <p:cNvPr id="607177604" name="Espace réservé du pied de page 5"/>
           <p:cNvSpPr>
             <a:spLocks noGrp="1"/>
           </p:cNvSpPr>
@@ -3917,7 +4019,7 @@
       </p:sp>
       <p:sp>
         <p:nvSpPr>
-          <p:cNvPr id="218975890" name="Espace réservé du numéro de diapositive 6"/>
+          <p:cNvPr id="1716130647" name="Espace réservé du numéro de diapositive 6"/>
           <p:cNvSpPr>
             <a:spLocks noGrp="1"/>
           </p:cNvSpPr>
@@ -3973,7 +4075,7 @@
       </p:grpSpPr>
       <p:sp>
         <p:nvSpPr>
-          <p:cNvPr id="1310574221" name="Espace réservé du titre 1"/>
+          <p:cNvPr id="492235718" name="Espace réservé du titre 1"/>
           <p:cNvSpPr>
             <a:spLocks noGrp="1"/>
           </p:cNvSpPr>
@@ -4009,7 +4111,7 @@
       </p:sp>
       <p:sp>
         <p:nvSpPr>
-          <p:cNvPr id="1505348625" name="Espace réservé du texte 2"/>
+          <p:cNvPr id="534894626" name="Espace réservé du texte 2"/>
           <p:cNvSpPr>
             <a:spLocks noGrp="1"/>
           </p:cNvSpPr>
@@ -4085,7 +4187,7 @@
       </p:sp>
       <p:sp>
         <p:nvSpPr>
-          <p:cNvPr id="1617478620" name="Espace réservé de la date 3"/>
+          <p:cNvPr id="2071193027" name="Espace réservé de la date 3"/>
           <p:cNvSpPr>
             <a:spLocks noGrp="1"/>
           </p:cNvSpPr>
@@ -4129,7 +4231,7 @@
       </p:sp>
       <p:sp>
         <p:nvSpPr>
-          <p:cNvPr id="1067707036" name="Espace réservé du pied de page 4"/>
+          <p:cNvPr id="2121387355" name="Espace réservé du pied de page 4"/>
           <p:cNvSpPr>
             <a:spLocks noGrp="1"/>
           </p:cNvSpPr>
@@ -4169,7 +4271,7 @@
       </p:sp>
       <p:sp>
         <p:nvSpPr>
-          <p:cNvPr id="1333560205" name="Espace réservé du numéro de diapositive 5"/>
+          <p:cNvPr id="8272115" name="Espace réservé du numéro de diapositive 5"/>
           <p:cNvSpPr>
             <a:spLocks noGrp="1"/>
           </p:cNvSpPr>
@@ -4530,7 +4632,7 @@
       </p:grpSpPr>
       <p:sp>
         <p:nvSpPr>
-          <p:cNvPr id="599145806" name="Title 1"/>
+          <p:cNvPr id="1255776247" name="Title 1"/>
           <p:cNvSpPr>
             <a:spLocks noGrp="1"/>
           </p:cNvSpPr>
@@ -4561,7 +4663,7 @@
       </p:sp>
       <p:sp>
         <p:nvSpPr>
-          <p:cNvPr id="746195870" name="Subtitle 2"/>
+          <p:cNvPr id="316090562" name="Subtitle 2"/>
           <p:cNvSpPr>
             <a:spLocks noGrp="1"/>
           </p:cNvSpPr>
@@ -4592,7 +4694,7 @@
       </p:sp>
       <p:sp>
         <p:nvSpPr>
-          <p:cNvPr id="1971701423" name="Espace réservé du numéro de diapositive 5"/>
+          <p:cNvPr id="1221779499" name="Espace réservé du numéro de diapositive 5"/>
           <p:cNvSpPr>
             <a:spLocks noGrp="1"/>
           </p:cNvSpPr>
@@ -4618,7 +4720,7 @@
       </p:sp>
       <p:sp>
         <p:nvSpPr>
-          <p:cNvPr id="2135210665" name="Espace réservé de la date 3"/>
+          <p:cNvPr id="1058201927" name="Espace réservé de la date 3"/>
           <p:cNvSpPr>
             <a:spLocks noGrp="1"/>
           </p:cNvSpPr>
@@ -4644,7 +4746,7 @@
       </p:sp>
       <p:pic>
         <p:nvPicPr>
-          <p:cNvPr id="59867102" name=""/>
+          <p:cNvPr id="714298522" name=""/>
           <p:cNvPicPr>
             <a:picLocks noChangeAspect="1"/>
           </p:cNvPicPr>
@@ -4699,7 +4801,7 @@
       </p:grpSpPr>
       <p:sp>
         <p:nvSpPr>
-          <p:cNvPr id="1665362919" name="Titre 1"/>
+          <p:cNvPr id="1615217383" name="Titre 1"/>
           <p:cNvSpPr>
             <a:spLocks noGrp="1"/>
           </p:cNvSpPr>
@@ -4716,23 +4818,16 @@
               <a:defRPr/>
             </a:pPr>
             <a:r>
-              <a:rPr lang="fr-FR" sz="4400" b="0" i="0" u="none" strike="noStrike" cap="none" spc="0">
-                <a:solidFill>
-                  <a:schemeClr val="tx1"/>
-                </a:solidFill>
-                <a:latin typeface="+mj-lt"/>
-                <a:ea typeface="+mj-ea"/>
-                <a:cs typeface="+mj-cs"/>
-              </a:rPr>
-              <a:t>Exemple of code #2</a:t>
-            </a:r>
-            <a:endParaRPr/>
-          </a:p>
-        </p:txBody>
-      </p:sp>
-      <p:sp>
-        <p:nvSpPr>
-          <p:cNvPr id="1777033340" name="Espace réservé de la date 2"/>
+              <a:rPr lang="fr-FR"/>
+              <a:t>Exemple of code #1</a:t>
+            </a:r>
+            <a:endParaRPr/>
+          </a:p>
+        </p:txBody>
+      </p:sp>
+      <p:sp>
+        <p:nvSpPr>
+          <p:cNvPr id="1601686499" name="Espace réservé de la date 2"/>
           <p:cNvSpPr>
             <a:spLocks noGrp="1"/>
           </p:cNvSpPr>
@@ -4758,7 +4853,7 @@
       </p:sp>
       <p:sp>
         <p:nvSpPr>
-          <p:cNvPr id="1183545330" name="Espace réservé du numéro de diapositive 4"/>
+          <p:cNvPr id="711914420" name="Espace réservé du numéro de diapositive 4"/>
           <p:cNvSpPr>
             <a:spLocks noGrp="1"/>
           </p:cNvSpPr>
@@ -4774,7 +4869,7 @@
             <a:pPr>
               <a:defRPr/>
             </a:pPr>
-            <a:fld id="{43049145-3055-3470-E904-AF1360FED3B1}" type="slidenum">
+            <a:fld id="{1A3A6BC6-A3CF-1FCD-B8B0-A4EF1A24EABF}" type="slidenum">
               <a:rPr lang="fr-FR"/>
               <a:t/>
             </a:fld>
@@ -4817,7 +4912,125 @@
       </p:grpSpPr>
       <p:sp>
         <p:nvSpPr>
-          <p:cNvPr id="689577517" name="Titre 1"/>
+          <p:cNvPr id="259592955" name="Titre 1"/>
+          <p:cNvSpPr>
+            <a:spLocks noGrp="1"/>
+          </p:cNvSpPr>
+          <p:nvPr>
+            <p:ph type="title"/>
+          </p:nvPr>
+        </p:nvSpPr>
+        <p:spPr bwMode="auto"/>
+        <p:txBody>
+          <a:bodyPr/>
+          <a:lstStyle/>
+          <a:p>
+            <a:pPr>
+              <a:defRPr/>
+            </a:pPr>
+            <a:r>
+              <a:rPr lang="fr-FR" sz="4400" b="0" i="0" u="none" strike="noStrike" cap="none" spc="0">
+                <a:solidFill>
+                  <a:schemeClr val="tx1"/>
+                </a:solidFill>
+                <a:latin typeface="+mj-lt"/>
+                <a:ea typeface="+mj-ea"/>
+                <a:cs typeface="+mj-cs"/>
+              </a:rPr>
+              <a:t>Exemple of code #2</a:t>
+            </a:r>
+            <a:endParaRPr/>
+          </a:p>
+        </p:txBody>
+      </p:sp>
+      <p:sp>
+        <p:nvSpPr>
+          <p:cNvPr id="466573792" name="Espace réservé de la date 2"/>
+          <p:cNvSpPr>
+            <a:spLocks noGrp="1"/>
+          </p:cNvSpPr>
+          <p:nvPr>
+            <p:ph type="dt" sz="half" idx="10"/>
+          </p:nvPr>
+        </p:nvSpPr>
+        <p:spPr bwMode="auto"/>
+        <p:txBody>
+          <a:bodyPr/>
+          <a:lstStyle/>
+          <a:p>
+            <a:pPr>
+              <a:defRPr/>
+            </a:pPr>
+            <a:r>
+              <a:rPr/>
+              <a:t>04/02/2026</a:t>
+            </a:r>
+            <a:endParaRPr/>
+          </a:p>
+        </p:txBody>
+      </p:sp>
+      <p:sp>
+        <p:nvSpPr>
+          <p:cNvPr id="921629484" name="Espace réservé du numéro de diapositive 4"/>
+          <p:cNvSpPr>
+            <a:spLocks noGrp="1"/>
+          </p:cNvSpPr>
+          <p:nvPr>
+            <p:ph type="sldNum" sz="quarter" idx="12"/>
+          </p:nvPr>
+        </p:nvSpPr>
+        <p:spPr bwMode="auto"/>
+        <p:txBody>
+          <a:bodyPr/>
+          <a:lstStyle/>
+          <a:p>
+            <a:pPr>
+              <a:defRPr/>
+            </a:pPr>
+            <a:fld id="{43049145-3055-3470-E904-AF1360FED3B1}" type="slidenum">
+              <a:rPr lang="fr-FR"/>
+              <a:t/>
+            </a:fld>
+            <a:endParaRPr lang="fr-FR"/>
+          </a:p>
+        </p:txBody>
+      </p:sp>
+    </p:spTree>
+  </p:cSld>
+  <p:clrMapOvr>
+    <a:masterClrMapping/>
+  </p:clrMapOvr>
+  <mc:AlternateContent xmlns:mc="http://schemas.openxmlformats.org/markup-compatibility/2006">
+    <mc:Choice xmlns:p159="http://schemas.microsoft.com/office/powerpoint/2015/09/main" xmlns:p14="http://schemas.microsoft.com/office/powerpoint/2010/main" Requires="p159">
+      <p:transition p14:dur="2000" advClick="1"/>
+    </mc:Choice>
+    <mc:Fallback>
+      <p:transition advClick="1"/>
+    </mc:Fallback>
+  </mc:AlternateContent>
+</p:sld>
+</file>
+
+<file path=ppt/slides/slide12.xml><?xml version="1.0" encoding="utf-8"?>
+<p:sld xmlns:a="http://schemas.openxmlformats.org/drawingml/2006/main" xmlns:r="http://schemas.openxmlformats.org/officeDocument/2006/relationships" xmlns:p="http://schemas.openxmlformats.org/presentationml/2006/main" xmlns:m="http://schemas.openxmlformats.org/officeDocument/2006/math" xmlns:w="http://schemas.openxmlformats.org/wordprocessingml/2006/main" xmlns:mc="http://schemas.openxmlformats.org/markup-compatibility/2006" showMasterPhAnim="0" showMasterSp="1" show="1">
+  <p:cSld name="">
+    <p:spTree>
+      <p:nvGrpSpPr>
+        <p:cNvPr id="1" name=""/>
+        <p:cNvGrpSpPr/>
+        <p:nvPr/>
+      </p:nvGrpSpPr>
+      <p:grpSpPr bwMode="auto">
+        <a:xfrm>
+          <a:off x="0" y="0"/>
+          <a:ext cx="0" cy="0"/>
+          <a:chOff x="0" y="0"/>
+          <a:chExt cx="0" cy="0"/>
+        </a:xfrm>
+      </p:grpSpPr>
+      <p:sp>
+        <p:nvSpPr>
+          <p:cNvPr id="954684596" name="Titre 1"/>
           <p:cNvSpPr>
             <a:spLocks noGrp="1"/>
           </p:cNvSpPr>
@@ -4850,7 +5063,7 @@
       </p:sp>
       <p:sp>
         <p:nvSpPr>
-          <p:cNvPr id="1059539457" name="Espace réservé de la date 2"/>
+          <p:cNvPr id="186283850" name="Espace réservé de la date 2"/>
           <p:cNvSpPr>
             <a:spLocks noGrp="1"/>
           </p:cNvSpPr>
@@ -4876,7 +5089,7 @@
       </p:sp>
       <p:sp>
         <p:nvSpPr>
-          <p:cNvPr id="1197395050" name="Espace réservé du numéro de diapositive 4"/>
+          <p:cNvPr id="942209459" name="Espace réservé du numéro de diapositive 4"/>
           <p:cNvSpPr>
             <a:spLocks noGrp="1"/>
           </p:cNvSpPr>
@@ -4935,7 +5148,7 @@
       </p:grpSpPr>
       <p:sp>
         <p:nvSpPr>
-          <p:cNvPr id="1207714675" name="Titre 1"/>
+          <p:cNvPr id="1793020423" name="Titre 1"/>
           <p:cNvSpPr>
             <a:spLocks noGrp="1"/>
           </p:cNvSpPr>
@@ -4961,7 +5174,7 @@
       </p:sp>
       <p:sp>
         <p:nvSpPr>
-          <p:cNvPr id="284123368" name="Espace réservé du contenu 2"/>
+          <p:cNvPr id="216973212" name="Espace réservé du contenu 2"/>
           <p:cNvSpPr>
             <a:spLocks noGrp="1"/>
           </p:cNvSpPr>
@@ -4988,7 +5201,7 @@
       </p:sp>
       <p:sp>
         <p:nvSpPr>
-          <p:cNvPr id="1375591627" name="Espace réservé du numéro de diapositive 5"/>
+          <p:cNvPr id="760035101" name="Espace réservé du numéro de diapositive 5"/>
           <p:cNvSpPr>
             <a:spLocks noGrp="1"/>
           </p:cNvSpPr>
@@ -5014,7 +5227,7 @@
       </p:sp>
       <p:sp>
         <p:nvSpPr>
-          <p:cNvPr id="965643081" name="Espace réservé de la date 3"/>
+          <p:cNvPr id="1471778160" name="Espace réservé de la date 3"/>
           <p:cNvSpPr>
             <a:spLocks noGrp="1"/>
           </p:cNvSpPr>
@@ -5040,7 +5253,7 @@
       </p:sp>
       <p:pic>
         <p:nvPicPr>
-          <p:cNvPr id="2014333340" name=""/>
+          <p:cNvPr id="642048866" name=""/>
           <p:cNvPicPr>
             <a:picLocks noChangeAspect="1"/>
           </p:cNvPicPr>
@@ -5096,7 +5309,7 @@
       </p:grpSpPr>
       <p:sp>
         <p:nvSpPr>
-          <p:cNvPr id="1305413442" name="Titre 1"/>
+          <p:cNvPr id="1959778119" name="Titre 1"/>
           <p:cNvSpPr>
             <a:spLocks noGrp="1"/>
           </p:cNvSpPr>
@@ -5122,7 +5335,7 @@
       </p:sp>
       <p:sp>
         <p:nvSpPr>
-          <p:cNvPr id="1473875778" name="Espace réservé du contenu 2"/>
+          <p:cNvPr id="918994536" name="Espace réservé du contenu 2"/>
           <p:cNvSpPr>
             <a:spLocks noGrp="1"/>
           </p:cNvSpPr>
@@ -5144,7 +5357,7 @@
       </p:sp>
       <p:sp>
         <p:nvSpPr>
-          <p:cNvPr id="2000260553" name="Espace réservé du numéro de diapositive 5"/>
+          <p:cNvPr id="257514003" name="Espace réservé du numéro de diapositive 5"/>
           <p:cNvSpPr>
             <a:spLocks noGrp="1"/>
           </p:cNvSpPr>
@@ -5170,7 +5383,7 @@
       </p:sp>
       <p:sp>
         <p:nvSpPr>
-          <p:cNvPr id="1224031798" name="Espace réservé de la date 3"/>
+          <p:cNvPr id="1948872305" name="Espace réservé de la date 3"/>
           <p:cNvSpPr>
             <a:spLocks noGrp="1"/>
           </p:cNvSpPr>
@@ -5229,7 +5442,7 @@
       </p:grpSpPr>
       <p:sp>
         <p:nvSpPr>
-          <p:cNvPr id="1793647362" name="Titre 1"/>
+          <p:cNvPr id="1942104705" name="Titre 1"/>
           <p:cNvSpPr>
             <a:spLocks noGrp="1"/>
           </p:cNvSpPr>
@@ -5262,7 +5475,7 @@
       </p:sp>
       <p:sp>
         <p:nvSpPr>
-          <p:cNvPr id="212014779" name="Espace réservé du contenu 2"/>
+          <p:cNvPr id="1386034613" name="Espace réservé du contenu 2"/>
           <p:cNvSpPr>
             <a:spLocks noGrp="1"/>
           </p:cNvSpPr>
@@ -5293,7 +5506,7 @@
       </p:sp>
       <p:sp>
         <p:nvSpPr>
-          <p:cNvPr id="650899715" name="Espace réservé du contenu 3"/>
+          <p:cNvPr id="1501225165" name="Espace réservé du contenu 3"/>
           <p:cNvSpPr>
             <a:spLocks noGrp="1"/>
           </p:cNvSpPr>
@@ -5318,13 +5531,17 @@
               <a:rPr/>
               <a:t>Lase</a:t>
             </a:r>
-            <a:endParaRPr/>
-          </a:p>
-        </p:txBody>
-      </p:sp>
-      <p:sp>
-        <p:nvSpPr>
-          <p:cNvPr id="656491572" name="Espace réservé du numéro de diapositive 6"/>
+            <a:r>
+              <a:rPr lang="fr-FR"/>
+              <a:t>r</a:t>
+            </a:r>
+            <a:endParaRPr/>
+          </a:p>
+        </p:txBody>
+      </p:sp>
+      <p:sp>
+        <p:nvSpPr>
+          <p:cNvPr id="1358067683" name="Espace réservé du numéro de diapositive 6"/>
           <p:cNvSpPr>
             <a:spLocks noGrp="1"/>
           </p:cNvSpPr>
@@ -5350,7 +5567,7 @@
       </p:sp>
       <p:sp>
         <p:nvSpPr>
-          <p:cNvPr id="978480078" name="Espace réservé de la date 4"/>
+          <p:cNvPr id="1001391507" name="Espace réservé de la date 4"/>
           <p:cNvSpPr>
             <a:spLocks noGrp="1"/>
           </p:cNvSpPr>
@@ -5409,7 +5626,7 @@
       </p:grpSpPr>
       <p:sp>
         <p:nvSpPr>
-          <p:cNvPr id="893369582" name="Titre 1"/>
+          <p:cNvPr id="1051094226" name="Titre 1"/>
           <p:cNvSpPr>
             <a:spLocks noGrp="1"/>
           </p:cNvSpPr>
@@ -5419,6 +5636,95 @@
         </p:nvSpPr>
         <p:spPr bwMode="auto"/>
         <p:txBody>
+          <a:bodyPr vertOverflow="overflow" horzOverflow="overflow" vert="horz" wrap="square" lIns="91440" tIns="45720" rIns="91440" bIns="45720" numCol="1" spcCol="0" rtlCol="0" fromWordArt="0" anchor="ctr" anchorCtr="0" forceAA="0" upright="0" compatLnSpc="0">
+            <a:normAutofit/>
+          </a:bodyPr>
+          <a:lstStyle/>
+          <a:p>
+            <a:pPr>
+              <a:defRPr/>
+            </a:pPr>
+            <a:r>
+              <a:rPr lang="fr-FR" sz="4400" b="0" i="0" u="none" strike="noStrike" cap="none" spc="0">
+                <a:solidFill>
+                  <a:schemeClr val="tx1"/>
+                </a:solidFill>
+                <a:latin typeface="Arial"/>
+                <a:ea typeface="Arial"/>
+                <a:cs typeface="Arial"/>
+              </a:rPr>
+              <a:t>Devellopement of communication Technology</a:t>
+            </a:r>
+            <a:endParaRPr sz="4400"/>
+          </a:p>
+        </p:txBody>
+      </p:sp>
+      <p:sp>
+        <p:nvSpPr>
+          <p:cNvPr id="1446329366" name="Espace réservé du contenu 2"/>
+          <p:cNvSpPr>
+            <a:spLocks noGrp="1"/>
+          </p:cNvSpPr>
+          <p:nvPr>
+            <p:ph sz="half" idx="1"/>
+          </p:nvPr>
+        </p:nvSpPr>
+        <p:spPr bwMode="auto">
+          <a:xfrm>
+            <a:off x="838199" y="1825624"/>
+            <a:ext cx="5181599" cy="4351338"/>
+          </a:xfrm>
+        </p:spPr>
+        <p:txBody>
+          <a:bodyPr/>
+          <a:lstStyle/>
+          <a:p>
+            <a:pPr>
+              <a:defRPr/>
+            </a:pPr>
+            <a:endParaRPr/>
+          </a:p>
+        </p:txBody>
+      </p:sp>
+      <p:sp>
+        <p:nvSpPr>
+          <p:cNvPr id="1296936065" name="Espace réservé du contenu 3"/>
+          <p:cNvSpPr>
+            <a:spLocks noGrp="1"/>
+          </p:cNvSpPr>
+          <p:nvPr>
+            <p:ph sz="half" idx="2"/>
+          </p:nvPr>
+        </p:nvSpPr>
+        <p:spPr bwMode="auto">
+          <a:xfrm>
+            <a:off x="6172200" y="1825624"/>
+            <a:ext cx="5181599" cy="4351338"/>
+          </a:xfrm>
+        </p:spPr>
+        <p:txBody>
+          <a:bodyPr/>
+          <a:lstStyle/>
+          <a:p>
+            <a:pPr>
+              <a:defRPr/>
+            </a:pPr>
+            <a:endParaRPr/>
+          </a:p>
+        </p:txBody>
+      </p:sp>
+      <p:sp>
+        <p:nvSpPr>
+          <p:cNvPr id="13352997" name="Espace réservé de la date 4"/>
+          <p:cNvSpPr>
+            <a:spLocks noGrp="1"/>
+          </p:cNvSpPr>
+          <p:nvPr>
+            <p:ph type="dt" sz="half" idx="10"/>
+          </p:nvPr>
+        </p:nvSpPr>
+        <p:spPr bwMode="auto"/>
+        <p:txBody>
           <a:bodyPr/>
           <a:lstStyle/>
           <a:p>
@@ -5427,37 +5733,15 @@
             </a:pPr>
             <a:r>
               <a:rPr/>
-              <a:t>RGB LEDs</a:t>
-            </a:r>
-            <a:endParaRPr/>
-          </a:p>
-        </p:txBody>
-      </p:sp>
-      <p:sp>
-        <p:nvSpPr>
-          <p:cNvPr id="1436195282" name="Espace réservé du contenu 2"/>
-          <p:cNvSpPr>
-            <a:spLocks noGrp="1"/>
-          </p:cNvSpPr>
-          <p:nvPr>
-            <p:ph idx="1"/>
-          </p:nvPr>
-        </p:nvSpPr>
-        <p:spPr bwMode="auto"/>
-        <p:txBody>
-          <a:bodyPr/>
-          <a:lstStyle/>
-          <a:p>
-            <a:pPr>
-              <a:defRPr/>
-            </a:pPr>
-            <a:endParaRPr/>
-          </a:p>
-        </p:txBody>
-      </p:sp>
-      <p:sp>
-        <p:nvSpPr>
-          <p:cNvPr id="227207917" name="Espace réservé du numéro de diapositive 5"/>
+              <a:t>04/02/2026</a:t>
+            </a:r>
+            <a:endParaRPr/>
+          </a:p>
+        </p:txBody>
+      </p:sp>
+      <p:sp>
+        <p:nvSpPr>
+          <p:cNvPr id="1119506242" name="Espace réservé du numéro de diapositive 6"/>
           <p:cNvSpPr>
             <a:spLocks noGrp="1"/>
           </p:cNvSpPr>
@@ -5473,37 +5757,11 @@
             <a:pPr>
               <a:defRPr/>
             </a:pPr>
-            <a:fld id="{F041B07B-4BE3-83D6-CBBE-6B3D0E28D179}" type="slidenum">
+            <a:fld id="{CBC5759C-0467-9260-2780-50138569D42C}" type="slidenum">
               <a:rPr lang="fr-FR"/>
               <a:t/>
             </a:fld>
-            <a:endParaRPr/>
-          </a:p>
-        </p:txBody>
-      </p:sp>
-      <p:sp>
-        <p:nvSpPr>
-          <p:cNvPr id="956192299" name="Espace réservé de la date 3"/>
-          <p:cNvSpPr>
-            <a:spLocks noGrp="1"/>
-          </p:cNvSpPr>
-          <p:nvPr>
-            <p:ph type="dt" sz="half" idx="10"/>
-          </p:nvPr>
-        </p:nvSpPr>
-        <p:spPr bwMode="auto"/>
-        <p:txBody>
-          <a:bodyPr/>
-          <a:lstStyle/>
-          <a:p>
-            <a:pPr>
-              <a:defRPr/>
-            </a:pPr>
-            <a:r>
-              <a:rPr/>
-              <a:t>04/02/2026</a:t>
-            </a:r>
-            <a:endParaRPr/>
+            <a:endParaRPr lang="fr-FR"/>
           </a:p>
         </p:txBody>
       </p:sp>
@@ -5542,7 +5800,7 @@
       </p:grpSpPr>
       <p:sp>
         <p:nvSpPr>
-          <p:cNvPr id="2033495573" name="Titre 1"/>
+          <p:cNvPr id="1678221039" name="Titre 1"/>
           <p:cNvSpPr>
             <a:spLocks noGrp="1"/>
           </p:cNvSpPr>
@@ -5568,7 +5826,7 @@
       </p:sp>
       <p:sp>
         <p:nvSpPr>
-          <p:cNvPr id="1219435151" name="Espace réservé du contenu 2"/>
+          <p:cNvPr id="1300701636" name="Espace réservé du contenu 2"/>
           <p:cNvSpPr>
             <a:spLocks noGrp="1"/>
           </p:cNvSpPr>
@@ -5590,7 +5848,7 @@
       </p:sp>
       <p:sp>
         <p:nvSpPr>
-          <p:cNvPr id="1285907199" name="Espace réservé du numéro de diapositive 5"/>
+          <p:cNvPr id="1551039914" name="Espace réservé du numéro de diapositive 5"/>
           <p:cNvSpPr>
             <a:spLocks noGrp="1"/>
           </p:cNvSpPr>
@@ -5616,7 +5874,7 @@
       </p:sp>
       <p:sp>
         <p:nvSpPr>
-          <p:cNvPr id="2065548379" name="Espace réservé de la date 3"/>
+          <p:cNvPr id="1985312033" name="Espace réservé de la date 3"/>
           <p:cNvSpPr>
             <a:spLocks noGrp="1"/>
           </p:cNvSpPr>
@@ -5675,7 +5933,7 @@
       </p:grpSpPr>
       <p:sp>
         <p:nvSpPr>
-          <p:cNvPr id="899933483" name="Titre 1"/>
+          <p:cNvPr id="745495665" name="Titre 1"/>
           <p:cNvSpPr>
             <a:spLocks noGrp="1"/>
           </p:cNvSpPr>
@@ -5693,15 +5951,15 @@
             </a:pPr>
             <a:r>
               <a:rPr/>
-              <a:t>Video of functionnality</a:t>
-            </a:r>
-            <a:endParaRPr/>
-          </a:p>
-        </p:txBody>
-      </p:sp>
-      <p:sp>
-        <p:nvSpPr>
-          <p:cNvPr id="101397041" name="Espace réservé du contenu 2"/>
+              <a:t>RGB LEDs</a:t>
+            </a:r>
+            <a:endParaRPr/>
+          </a:p>
+        </p:txBody>
+      </p:sp>
+      <p:sp>
+        <p:nvSpPr>
+          <p:cNvPr id="1692309627" name="Espace réservé du contenu 2"/>
           <p:cNvSpPr>
             <a:spLocks noGrp="1"/>
           </p:cNvSpPr>
@@ -5717,44 +5975,13 @@
             <a:pPr>
               <a:defRPr/>
             </a:pPr>
-            <a:r>
-              <a:rPr lang="fr-FR" sz="2800" b="0" i="0" u="none" strike="noStrike" cap="none" spc="0">
-                <a:solidFill>
-                  <a:schemeClr val="tx1"/>
-                </a:solidFill>
-                <a:latin typeface="Arial"/>
-                <a:ea typeface="Arial"/>
-                <a:cs typeface="Arial"/>
-              </a:rPr>
-              <a:t>feasibility</a:t>
-            </a:r>
-            <a:r>
-              <a:rPr/>
-              <a:t> of projet</a:t>
-            </a:r>
-            <a:endParaRPr/>
-          </a:p>
-          <a:p>
-            <a:pPr>
-              <a:defRPr/>
-            </a:pPr>
-            <a:r>
-              <a:rPr/>
-              <a:t>(Describing what is happening on the screen)</a:t>
-            </a:r>
-            <a:endParaRPr/>
-          </a:p>
-          <a:p>
-            <a:pPr>
-              <a:defRPr/>
-            </a:pPr>
-            <a:endParaRPr/>
-          </a:p>
-        </p:txBody>
-      </p:sp>
-      <p:sp>
-        <p:nvSpPr>
-          <p:cNvPr id="1652110690" name="Espace réservé du numéro de diapositive 5"/>
+            <a:endParaRPr/>
+          </a:p>
+        </p:txBody>
+      </p:sp>
+      <p:sp>
+        <p:nvSpPr>
+          <p:cNvPr id="596859281" name="Espace réservé du numéro de diapositive 5"/>
           <p:cNvSpPr>
             <a:spLocks noGrp="1"/>
           </p:cNvSpPr>
@@ -5770,7 +5997,7 @@
             <a:pPr>
               <a:defRPr/>
             </a:pPr>
-            <a:fld id="{D208D9F0-C16A-429C-FBEB-5E3ADF800BBD}" type="slidenum">
+            <a:fld id="{F041B07B-4BE3-83D6-CBBE-6B3D0E28D179}" type="slidenum">
               <a:rPr lang="fr-FR"/>
               <a:t/>
             </a:fld>
@@ -5780,7 +6007,7 @@
       </p:sp>
       <p:sp>
         <p:nvSpPr>
-          <p:cNvPr id="689387526" name="Espace réservé de la date 3"/>
+          <p:cNvPr id="574603365" name="Espace réservé de la date 3"/>
           <p:cNvSpPr>
             <a:spLocks noGrp="1"/>
           </p:cNvSpPr>
@@ -5800,6 +6027,28 @@
               <a:rPr/>
               <a:t>04/02/2026</a:t>
             </a:r>
+            <a:endParaRPr/>
+          </a:p>
+        </p:txBody>
+      </p:sp>
+      <p:sp>
+        <p:nvSpPr>
+          <p:cNvPr id="1325078919" name="Espace réservé du pied de page 4"/>
+          <p:cNvSpPr>
+            <a:spLocks noGrp="1"/>
+          </p:cNvSpPr>
+          <p:nvPr>
+            <p:ph type="ftr" sz="quarter" idx="11"/>
+          </p:nvPr>
+        </p:nvSpPr>
+        <p:spPr bwMode="auto"/>
+        <p:txBody>
+          <a:bodyPr/>
+          <a:lstStyle/>
+          <a:p>
+            <a:pPr>
+              <a:defRPr/>
+            </a:pPr>
             <a:endParaRPr/>
           </a:p>
         </p:txBody>
@@ -5839,7 +6088,7 @@
       </p:grpSpPr>
       <p:sp>
         <p:nvSpPr>
-          <p:cNvPr id="594385368" name="Titre 1"/>
+          <p:cNvPr id="1740746572" name="Titre 1"/>
           <p:cNvSpPr>
             <a:spLocks noGrp="1"/>
           </p:cNvSpPr>
@@ -5856,16 +6105,95 @@
               <a:defRPr/>
             </a:pPr>
             <a:r>
-              <a:rPr lang="fr-FR"/>
-              <a:t>Thank you for your attention</a:t>
-            </a:r>
-            <a:endParaRPr/>
-          </a:p>
-        </p:txBody>
-      </p:sp>
-      <p:sp>
-        <p:nvSpPr>
-          <p:cNvPr id="2109573538" name="Espace réservé de la date 2"/>
+              <a:rPr/>
+              <a:t>Video of functionnality</a:t>
+            </a:r>
+            <a:endParaRPr/>
+          </a:p>
+        </p:txBody>
+      </p:sp>
+      <p:sp>
+        <p:nvSpPr>
+          <p:cNvPr id="1784715862" name="Espace réservé du contenu 2"/>
+          <p:cNvSpPr>
+            <a:spLocks noGrp="1"/>
+          </p:cNvSpPr>
+          <p:nvPr>
+            <p:ph idx="1"/>
+          </p:nvPr>
+        </p:nvSpPr>
+        <p:spPr bwMode="auto"/>
+        <p:txBody>
+          <a:bodyPr/>
+          <a:lstStyle/>
+          <a:p>
+            <a:pPr>
+              <a:defRPr/>
+            </a:pPr>
+            <a:r>
+              <a:rPr lang="fr-FR" sz="2800" b="0" i="0" u="none" strike="noStrike" cap="none" spc="0">
+                <a:solidFill>
+                  <a:schemeClr val="tx1"/>
+                </a:solidFill>
+                <a:latin typeface="Arial"/>
+                <a:ea typeface="Arial"/>
+                <a:cs typeface="Arial"/>
+              </a:rPr>
+              <a:t>feasibility</a:t>
+            </a:r>
+            <a:r>
+              <a:rPr/>
+              <a:t> of projet</a:t>
+            </a:r>
+            <a:endParaRPr/>
+          </a:p>
+          <a:p>
+            <a:pPr>
+              <a:defRPr/>
+            </a:pPr>
+            <a:r>
+              <a:rPr/>
+              <a:t>(Describing what is happening on the screen)</a:t>
+            </a:r>
+            <a:endParaRPr/>
+          </a:p>
+          <a:p>
+            <a:pPr>
+              <a:defRPr/>
+            </a:pPr>
+            <a:endParaRPr/>
+          </a:p>
+        </p:txBody>
+      </p:sp>
+      <p:sp>
+        <p:nvSpPr>
+          <p:cNvPr id="2139708925" name="Espace réservé du numéro de diapositive 5"/>
+          <p:cNvSpPr>
+            <a:spLocks noGrp="1"/>
+          </p:cNvSpPr>
+          <p:nvPr>
+            <p:ph type="sldNum" sz="quarter" idx="12"/>
+          </p:nvPr>
+        </p:nvSpPr>
+        <p:spPr bwMode="auto"/>
+        <p:txBody>
+          <a:bodyPr/>
+          <a:lstStyle/>
+          <a:p>
+            <a:pPr>
+              <a:defRPr/>
+            </a:pPr>
+            <a:fld id="{D208D9F0-C16A-429C-FBEB-5E3ADF800BBD}" type="slidenum">
+              <a:rPr lang="fr-FR"/>
+              <a:t/>
+            </a:fld>
+            <a:endParaRPr/>
+          </a:p>
+        </p:txBody>
+      </p:sp>
+      <p:sp>
+        <p:nvSpPr>
+          <p:cNvPr id="2017471056" name="Espace réservé de la date 3"/>
           <p:cNvSpPr>
             <a:spLocks noGrp="1"/>
           </p:cNvSpPr>
@@ -5886,32 +6214,6 @@
               <a:t>04/02/2026</a:t>
             </a:r>
             <a:endParaRPr/>
-          </a:p>
-        </p:txBody>
-      </p:sp>
-      <p:sp>
-        <p:nvSpPr>
-          <p:cNvPr id="2137186509" name="Espace réservé du numéro de diapositive 4"/>
-          <p:cNvSpPr>
-            <a:spLocks noGrp="1"/>
-          </p:cNvSpPr>
-          <p:nvPr>
-            <p:ph type="sldNum" sz="quarter" idx="12"/>
-          </p:nvPr>
-        </p:nvSpPr>
-        <p:spPr bwMode="auto"/>
-        <p:txBody>
-          <a:bodyPr/>
-          <a:lstStyle/>
-          <a:p>
-            <a:pPr>
-              <a:defRPr/>
-            </a:pPr>
-            <a:fld id="{4159E1E4-1DDC-AAFE-4B0F-AF3554B29A48}" type="slidenum">
-              <a:rPr lang="fr-FR"/>
-              <a:t/>
-            </a:fld>
-            <a:endParaRPr lang="fr-FR"/>
           </a:p>
         </p:txBody>
       </p:sp>
@@ -5950,7 +6252,7 @@
       </p:grpSpPr>
       <p:sp>
         <p:nvSpPr>
-          <p:cNvPr id="1332190713" name="Titre 1"/>
+          <p:cNvPr id="695079900" name="Titre 1"/>
           <p:cNvSpPr>
             <a:spLocks noGrp="1"/>
           </p:cNvSpPr>
@@ -5968,15 +6270,15 @@
             </a:pPr>
             <a:r>
               <a:rPr lang="fr-FR"/>
-              <a:t>Exemple of code #1</a:t>
-            </a:r>
-            <a:endParaRPr/>
-          </a:p>
-        </p:txBody>
-      </p:sp>
-      <p:sp>
-        <p:nvSpPr>
-          <p:cNvPr id="701206748" name="Espace réservé de la date 2"/>
+              <a:t>Thank you for your attention</a:t>
+            </a:r>
+            <a:endParaRPr/>
+          </a:p>
+        </p:txBody>
+      </p:sp>
+      <p:sp>
+        <p:nvSpPr>
+          <p:cNvPr id="98579082" name="Espace réservé de la date 2"/>
           <p:cNvSpPr>
             <a:spLocks noGrp="1"/>
           </p:cNvSpPr>
@@ -6002,7 +6304,7 @@
       </p:sp>
       <p:sp>
         <p:nvSpPr>
-          <p:cNvPr id="101568447" name="Espace réservé du numéro de diapositive 4"/>
+          <p:cNvPr id="2031335436" name="Espace réservé du numéro de diapositive 4"/>
           <p:cNvSpPr>
             <a:spLocks noGrp="1"/>
           </p:cNvSpPr>
@@ -6018,7 +6320,7 @@
             <a:pPr>
               <a:defRPr/>
             </a:pPr>
-            <a:fld id="{1A3A6BC6-A3CF-1FCD-B8B0-A4EF1A24EABF}" type="slidenum">
+            <a:fld id="{4159E1E4-1DDC-AAFE-4B0F-AF3554B29A48}" type="slidenum">
               <a:rPr lang="fr-FR"/>
               <a:t/>
             </a:fld>

</xml_diff>